<commit_message>
Update email tracking and role documents for Palyr and MiVI groups; added new entries for MiVI_Miraen_Talvas_Couverture_salles and updated existing records with accurate preparation dates and PDF paths. Adjusted report generation timestamp in suivides envois.md to reflect the latest updates. Removed outdated entries to enhance clarity and consistency across player roles and reports.
</commit_message>
<xml_diff>
--- a/Groupes/Voleurs Corbeaux de minuit/Documents pour le jeu/Carte des coffres.pptx
+++ b/Groupes/Voleurs Corbeaux de minuit/Documents pour le jeu/Carte des coffres.pptx
@@ -5,10 +5,11 @@
     <p:sldMasterId id="2147483648" r:id="rId1"/>
   </p:sldMasterIdLst>
   <p:notesMasterIdLst>
-    <p:notesMasterId r:id="rId3"/>
+    <p:notesMasterId r:id="rId4"/>
   </p:notesMasterIdLst>
   <p:sldIdLst>
     <p:sldId id="257" r:id="rId2"/>
+    <p:sldId id="258" r:id="rId3"/>
   </p:sldIdLst>
   <p:sldSz cx="12192000" cy="6858000"/>
   <p:notesSz cx="6858000" cy="9144000"/>
@@ -118,7 +119,7 @@
 <file path=ppt/revisionInfo.xml><?xml version="1.0" encoding="utf-8"?>
 <p1510:revInfo xmlns:a="http://schemas.openxmlformats.org/drawingml/2006/main" xmlns:r="http://schemas.openxmlformats.org/officeDocument/2006/relationships" xmlns:p1510="http://schemas.microsoft.com/office/powerpoint/2015/10/main">
   <p1510:revLst>
-    <p1510:client id="{C0FA041F-38B5-46EC-96CD-F158F016DD51}" v="2" dt="2026-04-04T09:54:03.903"/>
+    <p1510:client id="{541F2838-7EEC-492B-873E-355EEBD32A6C}" v="1" dt="2026-06-26T15:27:23.815"/>
   </p1510:revLst>
 </p1510:revInfo>
 </file>
@@ -126,90 +127,26 @@
 <file path=ppt/changesInfos/changesInfo1.xml><?xml version="1.0" encoding="utf-8"?>
 <pc:chgInfo xmlns:a="http://schemas.openxmlformats.org/drawingml/2006/main" xmlns:r="http://schemas.openxmlformats.org/officeDocument/2006/relationships" xmlns:ac="http://schemas.microsoft.com/office/drawing/2013/main/command" xmlns:pc="http://schemas.microsoft.com/office/powerpoint/2013/main/command">
   <pc:docChgLst>
-    <pc:chgData name="LEDREUX Christophe" userId="25fb9e8f-a08b-443b-847d-7235dba123a2" providerId="ADAL" clId="{A876608C-F1AE-422C-926A-D547A3E0AF9F}"/>
-    <pc:docChg chg="custSel modSld">
-      <pc:chgData name="LEDREUX Christophe" userId="25fb9e8f-a08b-443b-847d-7235dba123a2" providerId="ADAL" clId="{A876608C-F1AE-422C-926A-D547A3E0AF9F}" dt="2026-04-04T09:54:38.559" v="45" actId="113"/>
+    <pc:chgData name="Sébastien Dury" userId="d8cfc095-b667-4ecf-8cea-02e4a80f4560" providerId="ADAL" clId="{C8EB9285-B058-4302-AB4B-E2874A1EEDE0}"/>
+    <pc:docChg chg="custSel addSld modSld">
+      <pc:chgData name="Sébastien Dury" userId="d8cfc095-b667-4ecf-8cea-02e4a80f4560" providerId="ADAL" clId="{C8EB9285-B058-4302-AB4B-E2874A1EEDE0}" dt="2026-06-26T15:27:27.817" v="1" actId="478"/>
       <pc:docMkLst>
         <pc:docMk/>
       </pc:docMkLst>
-      <pc:sldChg chg="addSp delSp modSp mod setBg">
-        <pc:chgData name="LEDREUX Christophe" userId="25fb9e8f-a08b-443b-847d-7235dba123a2" providerId="ADAL" clId="{A876608C-F1AE-422C-926A-D547A3E0AF9F}" dt="2026-04-04T09:54:38.559" v="45" actId="113"/>
+      <pc:sldChg chg="delSp add mod setBg">
+        <pc:chgData name="Sébastien Dury" userId="d8cfc095-b667-4ecf-8cea-02e4a80f4560" providerId="ADAL" clId="{C8EB9285-B058-4302-AB4B-E2874A1EEDE0}" dt="2026-06-26T15:27:27.817" v="1" actId="478"/>
         <pc:sldMkLst>
           <pc:docMk/>
-          <pc:sldMk cId="0" sldId="257"/>
+          <pc:sldMk cId="1846249872" sldId="258"/>
         </pc:sldMkLst>
-        <pc:spChg chg="mod">
-          <ac:chgData name="LEDREUX Christophe" userId="25fb9e8f-a08b-443b-847d-7235dba123a2" providerId="ADAL" clId="{A876608C-F1AE-422C-926A-D547A3E0AF9F}" dt="2026-04-04T09:54:02.436" v="19" actId="1076"/>
+        <pc:spChg chg="del">
+          <ac:chgData name="Sébastien Dury" userId="d8cfc095-b667-4ecf-8cea-02e4a80f4560" providerId="ADAL" clId="{C8EB9285-B058-4302-AB4B-E2874A1EEDE0}" dt="2026-06-26T15:27:27.817" v="1" actId="478"/>
           <ac:spMkLst>
             <pc:docMk/>
-            <pc:sldMk cId="0" sldId="257"/>
-            <ac:spMk id="3" creationId="{7DB99F58-3805-EA19-2A75-3438C50A0484}"/>
+            <pc:sldMk cId="1846249872" sldId="258"/>
+            <ac:spMk id="13" creationId="{448561B1-FB47-2A61-FFCE-E33078C081ED}"/>
           </ac:spMkLst>
         </pc:spChg>
-        <pc:spChg chg="mod">
-          <ac:chgData name="LEDREUX Christophe" userId="25fb9e8f-a08b-443b-847d-7235dba123a2" providerId="ADAL" clId="{A876608C-F1AE-422C-926A-D547A3E0AF9F}" dt="2026-04-04T09:54:38.559" v="45" actId="113"/>
-          <ac:spMkLst>
-            <pc:docMk/>
-            <pc:sldMk cId="0" sldId="257"/>
-            <ac:spMk id="5" creationId="{1DC5C2FC-5173-C4AE-2C32-B42FB6D0BC28}"/>
-          </ac:spMkLst>
-        </pc:spChg>
-        <pc:spChg chg="mod">
-          <ac:chgData name="LEDREUX Christophe" userId="25fb9e8f-a08b-443b-847d-7235dba123a2" providerId="ADAL" clId="{A876608C-F1AE-422C-926A-D547A3E0AF9F}" dt="2026-04-04T09:54:38.559" v="45" actId="113"/>
-          <ac:spMkLst>
-            <pc:docMk/>
-            <pc:sldMk cId="0" sldId="257"/>
-            <ac:spMk id="6" creationId="{255F6F6D-0600-9068-66FC-E66E3E4B0E13}"/>
-          </ac:spMkLst>
-        </pc:spChg>
-        <pc:spChg chg="add del mod">
-          <ac:chgData name="LEDREUX Christophe" userId="25fb9e8f-a08b-443b-847d-7235dba123a2" providerId="ADAL" clId="{A876608C-F1AE-422C-926A-D547A3E0AF9F}" dt="2026-04-04T09:53:53.324" v="18" actId="478"/>
-          <ac:spMkLst>
-            <pc:docMk/>
-            <pc:sldMk cId="0" sldId="257"/>
-            <ac:spMk id="7" creationId="{9152857F-952B-A8C4-8644-4E522A1495FC}"/>
-          </ac:spMkLst>
-        </pc:spChg>
-        <pc:spChg chg="add mod">
-          <ac:chgData name="LEDREUX Christophe" userId="25fb9e8f-a08b-443b-847d-7235dba123a2" providerId="ADAL" clId="{A876608C-F1AE-422C-926A-D547A3E0AF9F}" dt="2026-04-04T09:54:32.596" v="43" actId="1076"/>
-          <ac:spMkLst>
-            <pc:docMk/>
-            <pc:sldMk cId="0" sldId="257"/>
-            <ac:spMk id="8" creationId="{9E718AB7-7E72-C136-20B0-03E3388F95AD}"/>
-          </ac:spMkLst>
-        </pc:spChg>
-        <pc:spChg chg="mod">
-          <ac:chgData name="LEDREUX Christophe" userId="25fb9e8f-a08b-443b-847d-7235dba123a2" providerId="ADAL" clId="{A876608C-F1AE-422C-926A-D547A3E0AF9F}" dt="2026-04-04T09:54:38.559" v="45" actId="113"/>
-          <ac:spMkLst>
-            <pc:docMk/>
-            <pc:sldMk cId="0" sldId="257"/>
-            <ac:spMk id="12" creationId="{08DBBCCA-9643-73D9-0339-6C1CE4EDCA07}"/>
-          </ac:spMkLst>
-        </pc:spChg>
-        <pc:spChg chg="mod">
-          <ac:chgData name="LEDREUX Christophe" userId="25fb9e8f-a08b-443b-847d-7235dba123a2" providerId="ADAL" clId="{A876608C-F1AE-422C-926A-D547A3E0AF9F}" dt="2026-03-29T12:42:11.404" v="6" actId="20577"/>
-          <ac:spMkLst>
-            <pc:docMk/>
-            <pc:sldMk cId="0" sldId="257"/>
-            <ac:spMk id="13" creationId="{637A13C6-BC8C-08C1-96ED-AF2D32419801}"/>
-          </ac:spMkLst>
-        </pc:spChg>
-        <pc:picChg chg="add mod ord">
-          <ac:chgData name="LEDREUX Christophe" userId="25fb9e8f-a08b-443b-847d-7235dba123a2" providerId="ADAL" clId="{A876608C-F1AE-422C-926A-D547A3E0AF9F}" dt="2026-04-04T09:53:38.228" v="15" actId="29295"/>
-          <ac:picMkLst>
-            <pc:docMk/>
-            <pc:sldMk cId="0" sldId="257"/>
-            <ac:picMk id="4" creationId="{4A7AF870-2221-5801-5A17-C72F358E9557}"/>
-          </ac:picMkLst>
-        </pc:picChg>
-        <pc:picChg chg="del">
-          <ac:chgData name="LEDREUX Christophe" userId="25fb9e8f-a08b-443b-847d-7235dba123a2" providerId="ADAL" clId="{A876608C-F1AE-422C-926A-D547A3E0AF9F}" dt="2026-04-04T09:53:14.781" v="11" actId="478"/>
-          <ac:picMkLst>
-            <pc:docMk/>
-            <pc:sldMk cId="0" sldId="257"/>
-            <ac:picMk id="84" creationId="{00000000-0000-0000-0000-000000000000}"/>
-          </ac:picMkLst>
-        </pc:picChg>
       </pc:sldChg>
     </pc:docChg>
   </pc:docChgLst>
@@ -298,7 +235,7 @@
           <a:p>
             <a:fld id="{1FCD2E19-4E3C-40E1-A5E8-DD53F21D46DA}" type="datetimeFigureOut">
               <a:rPr lang="fr-FR" smtClean="0"/>
-              <a:t>04/04/2026</a:t>
+              <a:t>26/06/2026</a:t>
             </a:fld>
             <a:endParaRPr lang="fr-FR"/>
           </a:p>
@@ -456,7 +393,7 @@
           <a:p>
             <a:fld id="{2ADABFFA-FC27-4851-B3D7-9C0ADE4F5518}" type="slidenum">
               <a:rPr lang="fr-FR" smtClean="0"/>
-              <a:t>‹N°›</a:t>
+              <a:t>‹#›</a:t>
             </a:fld>
             <a:endParaRPr lang="fr-FR"/>
           </a:p>
@@ -669,6 +606,133 @@
 </p:notes>
 </file>
 
+<file path=ppt/notesSlides/notesSlide2.xml><?xml version="1.0" encoding="utf-8"?>
+<p:notes xmlns:a="http://schemas.openxmlformats.org/drawingml/2006/main" xmlns:r="http://schemas.openxmlformats.org/officeDocument/2006/relationships" xmlns:p="http://schemas.openxmlformats.org/presentationml/2006/main" showMasterSp="0" showMasterPhAnim="0">
+  <p:cSld>
+    <p:spTree>
+      <p:nvGrpSpPr>
+        <p:cNvPr id="1" name="Shape 80">
+          <a:extLst>
+            <a:ext uri="{FF2B5EF4-FFF2-40B4-BE49-F238E27FC236}">
+              <a16:creationId xmlns:a16="http://schemas.microsoft.com/office/drawing/2014/main" id="{682F0F5C-7824-23F7-EBD5-42A9AE7F9A4C}"/>
+            </a:ext>
+          </a:extLst>
+        </p:cNvPr>
+        <p:cNvGrpSpPr/>
+        <p:nvPr/>
+      </p:nvGrpSpPr>
+      <p:grpSpPr>
+        <a:xfrm>
+          <a:off x="0" y="0"/>
+          <a:ext cx="0" cy="0"/>
+          <a:chOff x="0" y="0"/>
+          <a:chExt cx="0" cy="0"/>
+        </a:xfrm>
+      </p:grpSpPr>
+      <p:sp>
+        <p:nvSpPr>
+          <p:cNvPr id="81" name="Google Shape;81;p1:notes">
+            <a:extLst>
+              <a:ext uri="{FF2B5EF4-FFF2-40B4-BE49-F238E27FC236}">
+                <a16:creationId xmlns:a16="http://schemas.microsoft.com/office/drawing/2014/main" id="{198E79B2-6A18-E67C-6C7D-FF14DAC45FCE}"/>
+              </a:ext>
+            </a:extLst>
+          </p:cNvPr>
+          <p:cNvSpPr txBox="1">
+            <a:spLocks noGrp="1"/>
+          </p:cNvSpPr>
+          <p:nvPr>
+            <p:ph type="body" idx="1"/>
+          </p:nvPr>
+        </p:nvSpPr>
+        <p:spPr>
+          <a:xfrm>
+            <a:off x="685800" y="4343400"/>
+            <a:ext cx="5486400" cy="4114800"/>
+          </a:xfrm>
+          <a:prstGeom prst="rect">
+            <a:avLst/>
+          </a:prstGeom>
+        </p:spPr>
+        <p:txBody>
+          <a:bodyPr spcFirstLastPara="1" wrap="square" lIns="91425" tIns="91425" rIns="91425" bIns="91425" anchor="t" anchorCtr="0">
+            <a:noAutofit/>
+          </a:bodyPr>
+          <a:lstStyle/>
+          <a:p>
+            <a:pPr marL="0" lvl="0" indent="0" algn="l" rtl="0">
+              <a:spcBef>
+                <a:spcPts val="0"/>
+              </a:spcBef>
+              <a:spcAft>
+                <a:spcPts val="0"/>
+              </a:spcAft>
+              <a:buNone/>
+            </a:pPr>
+            <a:endParaRPr/>
+          </a:p>
+        </p:txBody>
+      </p:sp>
+      <p:sp>
+        <p:nvSpPr>
+          <p:cNvPr id="82" name="Google Shape;82;p1:notes">
+            <a:extLst>
+              <a:ext uri="{FF2B5EF4-FFF2-40B4-BE49-F238E27FC236}">
+                <a16:creationId xmlns:a16="http://schemas.microsoft.com/office/drawing/2014/main" id="{339BAB3A-0BAC-D758-0C72-2CB9D5751E3A}"/>
+              </a:ext>
+            </a:extLst>
+          </p:cNvPr>
+          <p:cNvSpPr>
+            <a:spLocks noGrp="1" noRot="1" noChangeAspect="1"/>
+          </p:cNvSpPr>
+          <p:nvPr>
+            <p:ph type="sldImg" idx="2"/>
+          </p:nvPr>
+        </p:nvSpPr>
+        <p:spPr>
+          <a:xfrm>
+            <a:off x="381000" y="685800"/>
+            <a:ext cx="6096000" cy="3429000"/>
+          </a:xfrm>
+          <a:custGeom>
+            <a:avLst/>
+            <a:gdLst/>
+            <a:ahLst/>
+            <a:cxnLst/>
+            <a:rect l="l" t="t" r="r" b="b"/>
+            <a:pathLst>
+              <a:path w="120000" h="120000" extrusionOk="0">
+                <a:moveTo>
+                  <a:pt x="0" y="0"/>
+                </a:moveTo>
+                <a:lnTo>
+                  <a:pt x="120000" y="0"/>
+                </a:lnTo>
+                <a:lnTo>
+                  <a:pt x="120000" y="120000"/>
+                </a:lnTo>
+                <a:lnTo>
+                  <a:pt x="0" y="120000"/>
+                </a:lnTo>
+                <a:close/>
+              </a:path>
+            </a:pathLst>
+          </a:custGeom>
+        </p:spPr>
+      </p:sp>
+    </p:spTree>
+    <p:extLst>
+      <p:ext uri="{BB962C8B-B14F-4D97-AF65-F5344CB8AC3E}">
+        <p14:creationId xmlns:p14="http://schemas.microsoft.com/office/powerpoint/2010/main" val="2525409132"/>
+      </p:ext>
+    </p:extLst>
+  </p:cSld>
+  <p:clrMapOvr>
+    <a:masterClrMapping/>
+  </p:clrMapOvr>
+</p:notes>
+</file>
+
 <file path=ppt/slideLayouts/slideLayout1.xml><?xml version="1.0" encoding="utf-8"?>
 <p:sldLayout xmlns:a="http://schemas.openxmlformats.org/drawingml/2006/main" xmlns:r="http://schemas.openxmlformats.org/officeDocument/2006/relationships" xmlns:p="http://schemas.openxmlformats.org/presentationml/2006/main" type="title" preserve="1">
   <p:cSld name="Diapositive de titre">
@@ -816,7 +880,7 @@
           <a:p>
             <a:fld id="{92EC0475-6E87-4325-ABF1-AC12CCE34ADE}" type="datetimeFigureOut">
               <a:rPr lang="fr-FR" smtClean="0"/>
-              <a:t>04/04/2026</a:t>
+              <a:t>26/06/2026</a:t>
             </a:fld>
             <a:endParaRPr lang="fr-FR"/>
           </a:p>
@@ -870,7 +934,7 @@
           <a:p>
             <a:fld id="{64DEDC79-DD16-49DC-AB40-EE42C2746671}" type="slidenum">
               <a:rPr lang="fr-FR" smtClean="0"/>
-              <a:t>‹N°›</a:t>
+              <a:t>‹#›</a:t>
             </a:fld>
             <a:endParaRPr lang="fr-FR"/>
           </a:p>
@@ -1014,7 +1078,7 @@
           <a:p>
             <a:fld id="{92EC0475-6E87-4325-ABF1-AC12CCE34ADE}" type="datetimeFigureOut">
               <a:rPr lang="fr-FR" smtClean="0"/>
-              <a:t>04/04/2026</a:t>
+              <a:t>26/06/2026</a:t>
             </a:fld>
             <a:endParaRPr lang="fr-FR"/>
           </a:p>
@@ -1068,7 +1132,7 @@
           <a:p>
             <a:fld id="{64DEDC79-DD16-49DC-AB40-EE42C2746671}" type="slidenum">
               <a:rPr lang="fr-FR" smtClean="0"/>
-              <a:t>‹N°›</a:t>
+              <a:t>‹#›</a:t>
             </a:fld>
             <a:endParaRPr lang="fr-FR"/>
           </a:p>
@@ -1222,7 +1286,7 @@
           <a:p>
             <a:fld id="{92EC0475-6E87-4325-ABF1-AC12CCE34ADE}" type="datetimeFigureOut">
               <a:rPr lang="fr-FR" smtClean="0"/>
-              <a:t>04/04/2026</a:t>
+              <a:t>26/06/2026</a:t>
             </a:fld>
             <a:endParaRPr lang="fr-FR"/>
           </a:p>
@@ -1276,7 +1340,7 @@
           <a:p>
             <a:fld id="{64DEDC79-DD16-49DC-AB40-EE42C2746671}" type="slidenum">
               <a:rPr lang="fr-FR" smtClean="0"/>
-              <a:t>‹N°›</a:t>
+              <a:t>‹#›</a:t>
             </a:fld>
             <a:endParaRPr lang="fr-FR"/>
           </a:p>
@@ -1420,7 +1484,7 @@
           <a:p>
             <a:fld id="{92EC0475-6E87-4325-ABF1-AC12CCE34ADE}" type="datetimeFigureOut">
               <a:rPr lang="fr-FR" smtClean="0"/>
-              <a:t>04/04/2026</a:t>
+              <a:t>26/06/2026</a:t>
             </a:fld>
             <a:endParaRPr lang="fr-FR"/>
           </a:p>
@@ -1474,7 +1538,7 @@
           <a:p>
             <a:fld id="{64DEDC79-DD16-49DC-AB40-EE42C2746671}" type="slidenum">
               <a:rPr lang="fr-FR" smtClean="0"/>
-              <a:t>‹N°›</a:t>
+              <a:t>‹#›</a:t>
             </a:fld>
             <a:endParaRPr lang="fr-FR"/>
           </a:p>
@@ -1695,7 +1759,7 @@
           <a:p>
             <a:fld id="{92EC0475-6E87-4325-ABF1-AC12CCE34ADE}" type="datetimeFigureOut">
               <a:rPr lang="fr-FR" smtClean="0"/>
-              <a:t>04/04/2026</a:t>
+              <a:t>26/06/2026</a:t>
             </a:fld>
             <a:endParaRPr lang="fr-FR"/>
           </a:p>
@@ -1749,7 +1813,7 @@
           <a:p>
             <a:fld id="{64DEDC79-DD16-49DC-AB40-EE42C2746671}" type="slidenum">
               <a:rPr lang="fr-FR" smtClean="0"/>
-              <a:t>‹N°›</a:t>
+              <a:t>‹#›</a:t>
             </a:fld>
             <a:endParaRPr lang="fr-FR"/>
           </a:p>
@@ -1960,7 +2024,7 @@
           <a:p>
             <a:fld id="{92EC0475-6E87-4325-ABF1-AC12CCE34ADE}" type="datetimeFigureOut">
               <a:rPr lang="fr-FR" smtClean="0"/>
-              <a:t>04/04/2026</a:t>
+              <a:t>26/06/2026</a:t>
             </a:fld>
             <a:endParaRPr lang="fr-FR"/>
           </a:p>
@@ -2014,7 +2078,7 @@
           <a:p>
             <a:fld id="{64DEDC79-DD16-49DC-AB40-EE42C2746671}" type="slidenum">
               <a:rPr lang="fr-FR" smtClean="0"/>
-              <a:t>‹N°›</a:t>
+              <a:t>‹#›</a:t>
             </a:fld>
             <a:endParaRPr lang="fr-FR"/>
           </a:p>
@@ -2372,7 +2436,7 @@
           <a:p>
             <a:fld id="{92EC0475-6E87-4325-ABF1-AC12CCE34ADE}" type="datetimeFigureOut">
               <a:rPr lang="fr-FR" smtClean="0"/>
-              <a:t>04/04/2026</a:t>
+              <a:t>26/06/2026</a:t>
             </a:fld>
             <a:endParaRPr lang="fr-FR"/>
           </a:p>
@@ -2426,7 +2490,7 @@
           <a:p>
             <a:fld id="{64DEDC79-DD16-49DC-AB40-EE42C2746671}" type="slidenum">
               <a:rPr lang="fr-FR" smtClean="0"/>
-              <a:t>‹N°›</a:t>
+              <a:t>‹#›</a:t>
             </a:fld>
             <a:endParaRPr lang="fr-FR"/>
           </a:p>
@@ -2513,7 +2577,7 @@
           <a:p>
             <a:fld id="{92EC0475-6E87-4325-ABF1-AC12CCE34ADE}" type="datetimeFigureOut">
               <a:rPr lang="fr-FR" smtClean="0"/>
-              <a:t>04/04/2026</a:t>
+              <a:t>26/06/2026</a:t>
             </a:fld>
             <a:endParaRPr lang="fr-FR"/>
           </a:p>
@@ -2567,7 +2631,7 @@
           <a:p>
             <a:fld id="{64DEDC79-DD16-49DC-AB40-EE42C2746671}" type="slidenum">
               <a:rPr lang="fr-FR" smtClean="0"/>
-              <a:t>‹N°›</a:t>
+              <a:t>‹#›</a:t>
             </a:fld>
             <a:endParaRPr lang="fr-FR"/>
           </a:p>
@@ -2626,7 +2690,7 @@
           <a:p>
             <a:fld id="{92EC0475-6E87-4325-ABF1-AC12CCE34ADE}" type="datetimeFigureOut">
               <a:rPr lang="fr-FR" smtClean="0"/>
-              <a:t>04/04/2026</a:t>
+              <a:t>26/06/2026</a:t>
             </a:fld>
             <a:endParaRPr lang="fr-FR"/>
           </a:p>
@@ -2680,7 +2744,7 @@
           <a:p>
             <a:fld id="{64DEDC79-DD16-49DC-AB40-EE42C2746671}" type="slidenum">
               <a:rPr lang="fr-FR" smtClean="0"/>
-              <a:t>‹N°›</a:t>
+              <a:t>‹#›</a:t>
             </a:fld>
             <a:endParaRPr lang="fr-FR"/>
           </a:p>
@@ -2937,7 +3001,7 @@
           <a:p>
             <a:fld id="{92EC0475-6E87-4325-ABF1-AC12CCE34ADE}" type="datetimeFigureOut">
               <a:rPr lang="fr-FR" smtClean="0"/>
-              <a:t>04/04/2026</a:t>
+              <a:t>26/06/2026</a:t>
             </a:fld>
             <a:endParaRPr lang="fr-FR"/>
           </a:p>
@@ -2991,7 +3055,7 @@
           <a:p>
             <a:fld id="{64DEDC79-DD16-49DC-AB40-EE42C2746671}" type="slidenum">
               <a:rPr lang="fr-FR" smtClean="0"/>
-              <a:t>‹N°›</a:t>
+              <a:t>‹#›</a:t>
             </a:fld>
             <a:endParaRPr lang="fr-FR"/>
           </a:p>
@@ -3225,7 +3289,7 @@
           <a:p>
             <a:fld id="{92EC0475-6E87-4325-ABF1-AC12CCE34ADE}" type="datetimeFigureOut">
               <a:rPr lang="fr-FR" smtClean="0"/>
-              <a:t>04/04/2026</a:t>
+              <a:t>26/06/2026</a:t>
             </a:fld>
             <a:endParaRPr lang="fr-FR"/>
           </a:p>
@@ -3279,7 +3343,7 @@
           <a:p>
             <a:fld id="{64DEDC79-DD16-49DC-AB40-EE42C2746671}" type="slidenum">
               <a:rPr lang="fr-FR" smtClean="0"/>
-              <a:t>‹N°›</a:t>
+              <a:t>‹#›</a:t>
             </a:fld>
             <a:endParaRPr lang="fr-FR"/>
           </a:p>
@@ -3466,7 +3530,7 @@
           <a:p>
             <a:fld id="{92EC0475-6E87-4325-ABF1-AC12CCE34ADE}" type="datetimeFigureOut">
               <a:rPr lang="fr-FR" smtClean="0"/>
-              <a:t>04/04/2026</a:t>
+              <a:t>26/06/2026</a:t>
             </a:fld>
             <a:endParaRPr lang="fr-FR"/>
           </a:p>
@@ -3556,7 +3620,7 @@
           <a:p>
             <a:fld id="{64DEDC79-DD16-49DC-AB40-EE42C2746671}" type="slidenum">
               <a:rPr lang="fr-FR" smtClean="0"/>
-              <a:t>‹N°›</a:t>
+              <a:t>‹#›</a:t>
             </a:fld>
             <a:endParaRPr lang="fr-FR"/>
           </a:p>
@@ -4191,6 +4255,259 @@
         </p:txBody>
       </p:sp>
     </p:spTree>
+  </p:cSld>
+  <p:clrMapOvr>
+    <a:masterClrMapping/>
+  </p:clrMapOvr>
+</p:sld>
+</file>
+
+<file path=ppt/slides/slide2.xml><?xml version="1.0" encoding="utf-8"?>
+<p:sld xmlns:a="http://schemas.openxmlformats.org/drawingml/2006/main" xmlns:r="http://schemas.openxmlformats.org/officeDocument/2006/relationships" xmlns:p="http://schemas.openxmlformats.org/presentationml/2006/main">
+  <p:cSld>
+    <p:spTree>
+      <p:nvGrpSpPr>
+        <p:cNvPr id="1" name="Shape 83">
+          <a:extLst>
+            <a:ext uri="{FF2B5EF4-FFF2-40B4-BE49-F238E27FC236}">
+              <a16:creationId xmlns:a16="http://schemas.microsoft.com/office/drawing/2014/main" id="{FED309CF-39B2-2613-4AEE-E96473D270B8}"/>
+            </a:ext>
+          </a:extLst>
+        </p:cNvPr>
+        <p:cNvGrpSpPr/>
+        <p:nvPr/>
+      </p:nvGrpSpPr>
+      <p:grpSpPr>
+        <a:xfrm>
+          <a:off x="0" y="0"/>
+          <a:ext cx="0" cy="0"/>
+          <a:chOff x="0" y="0"/>
+          <a:chExt cx="0" cy="0"/>
+        </a:xfrm>
+      </p:grpSpPr>
+      <p:pic>
+        <p:nvPicPr>
+          <p:cNvPr id="4" name="Image 3">
+            <a:extLst>
+              <a:ext uri="{FF2B5EF4-FFF2-40B4-BE49-F238E27FC236}">
+                <a16:creationId xmlns:a16="http://schemas.microsoft.com/office/drawing/2014/main" id="{54EA4483-B789-D6AF-6F8C-F7237D562BD4}"/>
+              </a:ext>
+            </a:extLst>
+          </p:cNvPr>
+          <p:cNvPicPr>
+            <a:picLocks noChangeAspect="1"/>
+          </p:cNvPicPr>
+          <p:nvPr/>
+        </p:nvPicPr>
+        <p:blipFill>
+          <a:blip r:embed="rId3">
+            <a:alphaModFix amt="70000"/>
+          </a:blip>
+          <a:stretch>
+            <a:fillRect/>
+          </a:stretch>
+        </p:blipFill>
+        <p:spPr>
+          <a:xfrm>
+            <a:off x="0" y="6788"/>
+            <a:ext cx="9146541" cy="6851211"/>
+          </a:xfrm>
+          <a:prstGeom prst="rect">
+            <a:avLst/>
+          </a:prstGeom>
+        </p:spPr>
+      </p:pic>
+      <p:sp>
+        <p:nvSpPr>
+          <p:cNvPr id="3" name="ZoneTexte 2">
+            <a:extLst>
+              <a:ext uri="{FF2B5EF4-FFF2-40B4-BE49-F238E27FC236}">
+                <a16:creationId xmlns:a16="http://schemas.microsoft.com/office/drawing/2014/main" id="{EA81B29D-D9BB-9A21-A849-311B3B787F79}"/>
+              </a:ext>
+            </a:extLst>
+          </p:cNvPr>
+          <p:cNvSpPr txBox="1"/>
+          <p:nvPr/>
+        </p:nvSpPr>
+        <p:spPr>
+          <a:xfrm rot="19871694">
+            <a:off x="2820871" y="3845143"/>
+            <a:ext cx="793678" cy="307777"/>
+          </a:xfrm>
+          <a:prstGeom prst="rect">
+            <a:avLst/>
+          </a:prstGeom>
+          <a:noFill/>
+        </p:spPr>
+        <p:txBody>
+          <a:bodyPr wrap="square" rtlCol="0">
+            <a:spAutoFit/>
+          </a:bodyPr>
+          <a:lstStyle/>
+          <a:p>
+            <a:r>
+              <a:rPr lang="fr-FR" sz="1400" b="1" dirty="0">
+                <a:latin typeface="Bradley Hand ITC" panose="03070402050302030203" pitchFamily="66" charset="0"/>
+              </a:rPr>
+              <a:t>Banque</a:t>
+            </a:r>
+          </a:p>
+        </p:txBody>
+      </p:sp>
+      <p:sp>
+        <p:nvSpPr>
+          <p:cNvPr id="5" name="ZoneTexte 4">
+            <a:extLst>
+              <a:ext uri="{FF2B5EF4-FFF2-40B4-BE49-F238E27FC236}">
+                <a16:creationId xmlns:a16="http://schemas.microsoft.com/office/drawing/2014/main" id="{687F1445-42DD-CA4A-CBC6-0191E43F5D27}"/>
+              </a:ext>
+            </a:extLst>
+          </p:cNvPr>
+          <p:cNvSpPr txBox="1"/>
+          <p:nvPr/>
+        </p:nvSpPr>
+        <p:spPr>
+          <a:xfrm rot="19871694">
+            <a:off x="1238204" y="4208731"/>
+            <a:ext cx="1004790" cy="523220"/>
+          </a:xfrm>
+          <a:prstGeom prst="rect">
+            <a:avLst/>
+          </a:prstGeom>
+          <a:noFill/>
+        </p:spPr>
+        <p:txBody>
+          <a:bodyPr wrap="square" rtlCol="0">
+            <a:spAutoFit/>
+          </a:bodyPr>
+          <a:lstStyle/>
+          <a:p>
+            <a:r>
+              <a:rPr lang="fr-FR" sz="1400" b="1" dirty="0">
+                <a:latin typeface="Bradley Hand ITC" panose="03070402050302030203" pitchFamily="66" charset="0"/>
+              </a:rPr>
+              <a:t>Salle des coffres</a:t>
+            </a:r>
+          </a:p>
+        </p:txBody>
+      </p:sp>
+      <p:sp>
+        <p:nvSpPr>
+          <p:cNvPr id="6" name="ZoneTexte 5">
+            <a:extLst>
+              <a:ext uri="{FF2B5EF4-FFF2-40B4-BE49-F238E27FC236}">
+                <a16:creationId xmlns:a16="http://schemas.microsoft.com/office/drawing/2014/main" id="{59C5F516-1B7B-852F-F612-A6C9101006DF}"/>
+              </a:ext>
+            </a:extLst>
+          </p:cNvPr>
+          <p:cNvSpPr txBox="1"/>
+          <p:nvPr/>
+        </p:nvSpPr>
+        <p:spPr>
+          <a:xfrm rot="19871694">
+            <a:off x="1646637" y="4900627"/>
+            <a:ext cx="1004790" cy="523220"/>
+          </a:xfrm>
+          <a:prstGeom prst="rect">
+            <a:avLst/>
+          </a:prstGeom>
+          <a:noFill/>
+        </p:spPr>
+        <p:txBody>
+          <a:bodyPr wrap="square" rtlCol="0">
+            <a:spAutoFit/>
+          </a:bodyPr>
+          <a:lstStyle/>
+          <a:p>
+            <a:r>
+              <a:rPr lang="fr-FR" sz="1400" b="1" dirty="0">
+                <a:latin typeface="Bradley Hand ITC" panose="03070402050302030203" pitchFamily="66" charset="0"/>
+              </a:rPr>
+              <a:t>Salle des coffres</a:t>
+            </a:r>
+          </a:p>
+        </p:txBody>
+      </p:sp>
+      <p:sp>
+        <p:nvSpPr>
+          <p:cNvPr id="12" name="ZoneTexte 11">
+            <a:extLst>
+              <a:ext uri="{FF2B5EF4-FFF2-40B4-BE49-F238E27FC236}">
+                <a16:creationId xmlns:a16="http://schemas.microsoft.com/office/drawing/2014/main" id="{879457B6-8700-B2A1-FFF3-8FA96BDB7193}"/>
+              </a:ext>
+            </a:extLst>
+          </p:cNvPr>
+          <p:cNvSpPr txBox="1"/>
+          <p:nvPr/>
+        </p:nvSpPr>
+        <p:spPr>
+          <a:xfrm>
+            <a:off x="2715315" y="5300222"/>
+            <a:ext cx="1004790" cy="523220"/>
+          </a:xfrm>
+          <a:prstGeom prst="rect">
+            <a:avLst/>
+          </a:prstGeom>
+          <a:noFill/>
+        </p:spPr>
+        <p:txBody>
+          <a:bodyPr wrap="square" rtlCol="0">
+            <a:spAutoFit/>
+          </a:bodyPr>
+          <a:lstStyle/>
+          <a:p>
+            <a:r>
+              <a:rPr lang="fr-FR" sz="1400" b="1" dirty="0">
+                <a:latin typeface="Bradley Hand ITC" panose="03070402050302030203" pitchFamily="66" charset="0"/>
+              </a:rPr>
+              <a:t>Salle des coffres</a:t>
+            </a:r>
+          </a:p>
+        </p:txBody>
+      </p:sp>
+      <p:sp>
+        <p:nvSpPr>
+          <p:cNvPr id="8" name="ZoneTexte 7">
+            <a:extLst>
+              <a:ext uri="{FF2B5EF4-FFF2-40B4-BE49-F238E27FC236}">
+                <a16:creationId xmlns:a16="http://schemas.microsoft.com/office/drawing/2014/main" id="{7CD4EF6A-D4AE-308A-34E9-4B238B0FF991}"/>
+              </a:ext>
+            </a:extLst>
+          </p:cNvPr>
+          <p:cNvSpPr txBox="1"/>
+          <p:nvPr/>
+        </p:nvSpPr>
+        <p:spPr>
+          <a:xfrm>
+            <a:off x="3323266" y="2436231"/>
+            <a:ext cx="793678" cy="523220"/>
+          </a:xfrm>
+          <a:prstGeom prst="rect">
+            <a:avLst/>
+          </a:prstGeom>
+          <a:noFill/>
+        </p:spPr>
+        <p:txBody>
+          <a:bodyPr wrap="square" rtlCol="0">
+            <a:spAutoFit/>
+          </a:bodyPr>
+          <a:lstStyle/>
+          <a:p>
+            <a:r>
+              <a:rPr lang="fr-FR" sz="1400" b="1" dirty="0">
+                <a:latin typeface="Bradley Hand ITC" panose="03070402050302030203" pitchFamily="66" charset="0"/>
+              </a:rPr>
+              <a:t>Auberge et tripot</a:t>
+            </a:r>
+          </a:p>
+        </p:txBody>
+      </p:sp>
+    </p:spTree>
+    <p:extLst>
+      <p:ext uri="{BB962C8B-B14F-4D97-AF65-F5344CB8AC3E}">
+        <p14:creationId xmlns:p14="http://schemas.microsoft.com/office/powerpoint/2010/main" val="1846249872"/>
+      </p:ext>
+    </p:extLst>
   </p:cSld>
   <p:clrMapOvr>
     <a:masterClrMapping/>

</xml_diff>